<commit_message>
Adjust presentation slides for improved layout and content accuracy
Update presentation metadata and the main presentation file to correct overlapping content and ensure accurate display of information on specific slides.

Replit-Commit-Author: Agent
Replit-Commit-Session-Id: 85f09f3c-352d-446d-b98e-3f307c26fc5a
Replit-Commit-Checkpoint-Type: full_checkpoint
Replit-Commit-Event-Id: f108a297-5e09-484d-8794-4120166c587d
Replit-Commit-Screenshot-Url: https://storage.googleapis.com/screenshot-production-us-central1/3bd53afc-ff4f-401b-9e3d-b367791ef629/85f09f3c-352d-446d-b98e-3f307c26fc5a/m89sPBp
Replit-Helium-Checkpoint-Created: true
</commit_message>
<xml_diff>
--- a/attached_assets/VaughnMartin-Investor-Deck-v12.pptx
+++ b/attached_assets/VaughnMartin-Investor-Deck-v12.pptx
@@ -12343,30 +12343,6 @@
           <a:chExt cx="0" cy="0"/>
         </a:xfrm>
       </p:grpSpPr>
-      <p:pic>
-        <p:nvPicPr>
-          <p:cNvPr id="18" name="Picture 17" descr="deck_how_it_executes.jpg"/>
-          <p:cNvPicPr>
-            <a:picLocks noChangeAspect="1"/>
-          </p:cNvPicPr>
-          <p:nvPr/>
-        </p:nvPicPr>
-        <p:blipFill>
-          <a:blip r:embed="rId4"/>
-          <a:stretch>
-            <a:fillRect/>
-          </a:stretch>
-        </p:blipFill>
-        <p:spPr>
-          <a:xfrm>
-            <a:off x="5943600" y="1097280"/>
-            <a:ext cx="5852160" cy="5303520"/>
-          </a:xfrm>
-          <a:prstGeom prst="rect">
-            <a:avLst/>
-          </a:prstGeom>
-        </p:spPr>
-      </p:pic>
       <p:sp>
         <p:nvSpPr>
           <p:cNvPr id="2" name="Rectangle 1"/>
@@ -14913,30 +14889,6 @@
           <a:chExt cx="0" cy="0"/>
         </a:xfrm>
       </p:grpSpPr>
-      <p:pic>
-        <p:nvPicPr>
-          <p:cNvPr id="31" name="Picture 30" descr="deck_proof_story.jpg"/>
-          <p:cNvPicPr>
-            <a:picLocks noChangeAspect="1"/>
-          </p:cNvPicPr>
-          <p:nvPr/>
-        </p:nvPicPr>
-        <p:blipFill>
-          <a:blip r:embed="rId4"/>
-          <a:stretch>
-            <a:fillRect/>
-          </a:stretch>
-        </p:blipFill>
-        <p:spPr>
-          <a:xfrm>
-            <a:off x="5943600" y="914400"/>
-            <a:ext cx="5852160" cy="5486400"/>
-          </a:xfrm>
-          <a:prstGeom prst="rect">
-            <a:avLst/>
-          </a:prstGeom>
-        </p:spPr>
-      </p:pic>
       <p:sp>
         <p:nvSpPr>
           <p:cNvPr id="2" name="Rectangle 1"/>
@@ -16048,30 +16000,6 @@
           <a:chExt cx="0" cy="0"/>
         </a:xfrm>
       </p:grpSpPr>
-      <p:pic>
-        <p:nvPicPr>
-          <p:cNvPr id="49" name="Picture 48" descr="deck_roi_calculator.jpg"/>
-          <p:cNvPicPr>
-            <a:picLocks noChangeAspect="1"/>
-          </p:cNvPicPr>
-          <p:nvPr/>
-        </p:nvPicPr>
-        <p:blipFill>
-          <a:blip r:embed="rId3"/>
-          <a:stretch>
-            <a:fillRect/>
-          </a:stretch>
-        </p:blipFill>
-        <p:spPr>
-          <a:xfrm>
-            <a:off x="5760720" y="914400"/>
-            <a:ext cx="6035040" cy="5486400"/>
-          </a:xfrm>
-          <a:prstGeom prst="rect">
-            <a:avLst/>
-          </a:prstGeom>
-        </p:spPr>
-      </p:pic>
       <p:sp>
         <p:nvSpPr>
           <p:cNvPr id="2" name="Rectangle 1"/>
@@ -17876,8 +17804,8 @@
         </p:blipFill>
         <p:spPr>
           <a:xfrm>
-            <a:off x="137160" y="2560320"/>
-            <a:ext cx="11887200" cy="4023360"/>
+            <a:off x="128016" y="2633472"/>
+            <a:ext cx="11942064" cy="3163824"/>
           </a:xfrm>
           <a:prstGeom prst="rect">
             <a:avLst/>

</xml_diff>